<commit_message>
Rediseño S01+S02 con fondos cinematograficos
</commit_message>
<xml_diff>
--- a/Domingo-14/S01_Domingo-14_1_Post_El-pendiente-de-la-semana.pptx
+++ b/Domingo-14/S01_Domingo-14_1_Post_El-pendiente-de-la-semana.pptx
@@ -3084,7 +3084,7 @@
     <p:bg>
       <p:bgPr>
         <a:solidFill>
-          <a:srgbClr val="FFFFFF"/>
+          <a:srgbClr val="0F172A"/>
         </a:solidFill>
         <a:effectLst/>
       </p:bgPr>
@@ -3096,9 +3096,135 @@
         <p:nvPr/>
       </p:nvGrpSpPr>
       <p:grpSpPr/>
-      <p:sp>
-        <p:nvSpPr>
-          <p:cNvPr id="2" name="Rounded Rectangle 1"/>
+      <p:pic>
+        <p:nvPicPr>
+          <p:cNvPr id="2" name="Picture 1" descr="oficina.png"/>
+          <p:cNvPicPr>
+            <a:picLocks noChangeAspect="1"/>
+          </p:cNvPicPr>
+          <p:nvPr/>
+        </p:nvPicPr>
+        <p:blipFill>
+          <a:blip r:embed="rId2"/>
+          <a:stretch>
+            <a:fillRect/>
+          </a:stretch>
+        </p:blipFill>
+        <p:spPr>
+          <a:xfrm>
+            <a:off x="0" y="-342900"/>
+            <a:ext cx="8229600" cy="10972800"/>
+          </a:xfrm>
+          <a:prstGeom prst="rect">
+            <a:avLst/>
+          </a:prstGeom>
+        </p:spPr>
+      </p:pic>
+      <p:sp>
+        <p:nvSpPr>
+          <p:cNvPr id="3" name="Rectangle 2"/>
+          <p:cNvSpPr/>
+          <p:nvPr/>
+        </p:nvSpPr>
+        <p:spPr>
+          <a:xfrm>
+            <a:off x="0" y="0"/>
+            <a:ext cx="8229600" cy="10287000"/>
+          </a:xfrm>
+          <a:prstGeom prst="rect">
+            <a:avLst/>
+          </a:prstGeom>
+          <a:solidFill>
+            <a:srgbClr val="0F172A">
+              <a:alpha val="50000"/>
+            </a:srgbClr>
+          </a:solidFill>
+          <a:ln>
+            <a:noFill/>
+          </a:ln>
+          <a:effectLst/>
+        </p:spPr>
+        <p:style>
+          <a:lnRef idx="1">
+            <a:schemeClr val="accent1"/>
+          </a:lnRef>
+          <a:fillRef idx="3">
+            <a:schemeClr val="accent1"/>
+          </a:fillRef>
+          <a:effectRef idx="2">
+            <a:schemeClr val="accent1"/>
+          </a:effectRef>
+          <a:fontRef idx="minor">
+            <a:schemeClr val="lt1"/>
+          </a:fontRef>
+        </p:style>
+        <p:txBody>
+          <a:bodyPr rtlCol="0" anchor="ctr"/>
+          <a:lstStyle/>
+          <a:p>
+            <a:pPr algn="ctr"/>
+          </a:p>
+        </p:txBody>
+      </p:sp>
+      <p:sp>
+        <p:nvSpPr>
+          <p:cNvPr id="4" name="Rectangle 3"/>
+          <p:cNvSpPr/>
+          <p:nvPr/>
+        </p:nvSpPr>
+        <p:spPr>
+          <a:xfrm>
+            <a:off x="0" y="8915400"/>
+            <a:ext cx="8229600" cy="1371600"/>
+          </a:xfrm>
+          <a:prstGeom prst="rect">
+            <a:avLst/>
+          </a:prstGeom>
+          <a:gradFill>
+            <a:gsLst>
+              <a:gs pos="0">
+                <a:srgbClr val="0F172A">
+                  <a:alpha val="0"/>
+                </a:srgbClr>
+              </a:gs>
+              <a:gs pos="100000">
+                <a:srgbClr val="0F172A">
+                  <a:alpha val="78000"/>
+                </a:srgbClr>
+              </a:gs>
+            </a:gsLst>
+            <a:lin ang="5400000" scaled="1"/>
+          </a:gradFill>
+          <a:ln>
+            <a:noFill/>
+          </a:ln>
+          <a:effectLst/>
+        </p:spPr>
+        <p:style>
+          <a:lnRef idx="1">
+            <a:schemeClr val="accent1"/>
+          </a:lnRef>
+          <a:fillRef idx="3">
+            <a:schemeClr val="accent1"/>
+          </a:fillRef>
+          <a:effectRef idx="2">
+            <a:schemeClr val="accent1"/>
+          </a:effectRef>
+          <a:fontRef idx="minor">
+            <a:schemeClr val="lt1"/>
+          </a:fontRef>
+        </p:style>
+        <p:txBody>
+          <a:bodyPr rtlCol="0" anchor="ctr"/>
+          <a:lstStyle/>
+          <a:p>
+            <a:pPr algn="ctr"/>
+          </a:p>
+        </p:txBody>
+      </p:sp>
+      <p:sp>
+        <p:nvSpPr>
+          <p:cNvPr id="5" name="Rounded Rectangle 4"/>
           <p:cNvSpPr/>
           <p:nvPr/>
         </p:nvSpPr>
@@ -3153,7 +3279,7 @@
       </p:sp>
       <p:sp>
         <p:nvSpPr>
-          <p:cNvPr id="3" name="Rectangle 2"/>
+          <p:cNvPr id="6" name="Rectangle 5"/>
           <p:cNvSpPr/>
           <p:nvPr/>
         </p:nvSpPr>
@@ -3197,7 +3323,7 @@
       </p:sp>
       <p:sp>
         <p:nvSpPr>
-          <p:cNvPr id="4" name="TextBox 3"/>
+          <p:cNvPr id="7" name="TextBox 6"/>
           <p:cNvSpPr txBox="1"/>
           <p:nvPr/>
         </p:nvSpPr>
@@ -3225,7 +3351,7 @@
             <a:r>
               <a:rPr sz="7200" b="1">
                 <a:solidFill>
-                  <a:srgbClr val="0F172A"/>
+                  <a:srgbClr val="FFFFFF"/>
                 </a:solidFill>
                 <a:latin typeface="Inter"/>
               </a:rPr>
@@ -3236,7 +3362,7 @@
       </p:sp>
       <p:sp>
         <p:nvSpPr>
-          <p:cNvPr id="5" name="TextBox 4"/>
+          <p:cNvPr id="8" name="TextBox 7"/>
           <p:cNvSpPr txBox="1"/>
           <p:nvPr/>
         </p:nvSpPr>
@@ -3273,7 +3399,7 @@
             <a:r>
               <a:rPr sz="1800" b="1">
                 <a:solidFill>
-                  <a:srgbClr val="0F172A"/>
+                  <a:srgbClr val="FFFFFF"/>
                 </a:solidFill>
                 <a:latin typeface="Inter"/>
               </a:rPr>

</xml_diff>